<commit_message>
fix: restore visible PPTX header contrast
</commit_message>
<xml_diff>
--- a/docs/operators/evidence/sw012-buehne-20260711/education/public/presentation.pptx
+++ b/docs/operators/evidence/sw012-buehne-20260711/education/public/presentation.pptx
@@ -3170,7 +3170,7 @@
             <a:r>
               <a:rPr sz="1100" b="1">
                 <a:solidFill>
-                  <a:srgbClr val="14213D"/>
+                  <a:srgbClr val="FFFFFF"/>
                 </a:solidFill>
                 <a:latin typeface="Arial"/>
               </a:rPr>
@@ -3205,7 +3205,7 @@
             <a:r>
               <a:rPr sz="1100" b="1">
                 <a:solidFill>
-                  <a:srgbClr val="14213D"/>
+                  <a:srgbClr val="FFFFFF"/>
                 </a:solidFill>
                 <a:latin typeface="Arial"/>
               </a:rPr>
@@ -3419,7 +3419,7 @@
             <a:r>
               <a:rPr sz="1100" b="1">
                 <a:solidFill>
-                  <a:srgbClr val="14213D"/>
+                  <a:srgbClr val="FFFFFF"/>
                 </a:solidFill>
                 <a:latin typeface="Arial"/>
               </a:rPr>
@@ -3454,7 +3454,7 @@
             <a:r>
               <a:rPr sz="1100" b="1">
                 <a:solidFill>
-                  <a:srgbClr val="14213D"/>
+                  <a:srgbClr val="FFFFFF"/>
                 </a:solidFill>
                 <a:latin typeface="Arial"/>
               </a:rPr>
@@ -3671,7 +3671,7 @@
             <a:r>
               <a:rPr sz="1100" b="1">
                 <a:solidFill>
-                  <a:srgbClr val="14213D"/>
+                  <a:srgbClr val="FFFFFF"/>
                 </a:solidFill>
                 <a:latin typeface="Arial"/>
               </a:rPr>
@@ -3706,7 +3706,7 @@
             <a:r>
               <a:rPr sz="1100" b="1">
                 <a:solidFill>
-                  <a:srgbClr val="14213D"/>
+                  <a:srgbClr val="FFFFFF"/>
                 </a:solidFill>
                 <a:latin typeface="Arial"/>
               </a:rPr>
@@ -3955,7 +3955,7 @@
             <a:r>
               <a:rPr sz="1100" b="1">
                 <a:solidFill>
-                  <a:srgbClr val="14213D"/>
+                  <a:srgbClr val="FFFFFF"/>
                 </a:solidFill>
                 <a:latin typeface="Arial"/>
               </a:rPr>
@@ -3990,7 +3990,7 @@
             <a:r>
               <a:rPr sz="1100" b="1">
                 <a:solidFill>
-                  <a:srgbClr val="14213D"/>
+                  <a:srgbClr val="FFFFFF"/>
                 </a:solidFill>
                 <a:latin typeface="Arial"/>
               </a:rPr>
@@ -4239,7 +4239,7 @@
             <a:r>
               <a:rPr sz="1100" b="1">
                 <a:solidFill>
-                  <a:srgbClr val="14213D"/>
+                  <a:srgbClr val="FFFFFF"/>
                 </a:solidFill>
                 <a:latin typeface="Arial"/>
               </a:rPr>
@@ -4274,7 +4274,7 @@
             <a:r>
               <a:rPr sz="1100" b="1">
                 <a:solidFill>
-                  <a:srgbClr val="14213D"/>
+                  <a:srgbClr val="FFFFFF"/>
                 </a:solidFill>
                 <a:latin typeface="Arial"/>
               </a:rPr>
@@ -4523,7 +4523,7 @@
             <a:r>
               <a:rPr sz="1100" b="1">
                 <a:solidFill>
-                  <a:srgbClr val="14213D"/>
+                  <a:srgbClr val="FFFFFF"/>
                 </a:solidFill>
                 <a:latin typeface="Arial"/>
               </a:rPr>
@@ -4558,7 +4558,7 @@
             <a:r>
               <a:rPr sz="1100" b="1">
                 <a:solidFill>
-                  <a:srgbClr val="14213D"/>
+                  <a:srgbClr val="FFFFFF"/>
                 </a:solidFill>
                 <a:latin typeface="Arial"/>
               </a:rPr>

</xml_diff>